<commit_message>
Session 6: format tweaks to slides
</commit_message>
<xml_diff>
--- a/assets/downloads/Session-6-Build-Something-Real.pptx
+++ b/assets/downloads/Session-6-Build-Something-Real.pptx
@@ -5,40 +5,40 @@
     <p:sldMasterId id="2147483648" r:id="rId1"/>
   </p:sldMasterIdLst>
   <p:sldIdLst>
-    <p:sldId id="256" r:id="rId7"/>
-    <p:sldId id="257" r:id="rId8"/>
-    <p:sldId id="258" r:id="rId9"/>
-    <p:sldId id="259" r:id="rId10"/>
-    <p:sldId id="260" r:id="rId11"/>
-    <p:sldId id="261" r:id="rId12"/>
-    <p:sldId id="262" r:id="rId13"/>
-    <p:sldId id="263" r:id="rId14"/>
-    <p:sldId id="264" r:id="rId15"/>
-    <p:sldId id="265" r:id="rId16"/>
-    <p:sldId id="266" r:id="rId17"/>
-    <p:sldId id="267" r:id="rId18"/>
-    <p:sldId id="268" r:id="rId19"/>
-    <p:sldId id="269" r:id="rId20"/>
-    <p:sldId id="270" r:id="rId21"/>
-    <p:sldId id="271" r:id="rId22"/>
-    <p:sldId id="272" r:id="rId23"/>
-    <p:sldId id="273" r:id="rId24"/>
-    <p:sldId id="274" r:id="rId25"/>
-    <p:sldId id="275" r:id="rId26"/>
-    <p:sldId id="276" r:id="rId27"/>
-    <p:sldId id="277" r:id="rId28"/>
-    <p:sldId id="278" r:id="rId29"/>
-    <p:sldId id="279" r:id="rId30"/>
-    <p:sldId id="280" r:id="rId31"/>
-    <p:sldId id="281" r:id="rId32"/>
-    <p:sldId id="282" r:id="rId33"/>
-    <p:sldId id="283" r:id="rId34"/>
-    <p:sldId id="284" r:id="rId35"/>
-    <p:sldId id="285" r:id="rId36"/>
-    <p:sldId id="286" r:id="rId37"/>
-    <p:sldId id="287" r:id="rId38"/>
+    <p:sldId id="256" r:id="rId2"/>
+    <p:sldId id="257" r:id="rId3"/>
+    <p:sldId id="258" r:id="rId4"/>
+    <p:sldId id="259" r:id="rId5"/>
+    <p:sldId id="260" r:id="rId6"/>
+    <p:sldId id="261" r:id="rId7"/>
+    <p:sldId id="262" r:id="rId8"/>
+    <p:sldId id="263" r:id="rId9"/>
+    <p:sldId id="264" r:id="rId10"/>
+    <p:sldId id="265" r:id="rId11"/>
+    <p:sldId id="266" r:id="rId12"/>
+    <p:sldId id="267" r:id="rId13"/>
+    <p:sldId id="268" r:id="rId14"/>
+    <p:sldId id="269" r:id="rId15"/>
+    <p:sldId id="270" r:id="rId16"/>
+    <p:sldId id="271" r:id="rId17"/>
+    <p:sldId id="272" r:id="rId18"/>
+    <p:sldId id="273" r:id="rId19"/>
+    <p:sldId id="274" r:id="rId20"/>
+    <p:sldId id="275" r:id="rId21"/>
+    <p:sldId id="276" r:id="rId22"/>
+    <p:sldId id="277" r:id="rId23"/>
+    <p:sldId id="278" r:id="rId24"/>
+    <p:sldId id="279" r:id="rId25"/>
+    <p:sldId id="280" r:id="rId26"/>
+    <p:sldId id="281" r:id="rId27"/>
+    <p:sldId id="282" r:id="rId28"/>
+    <p:sldId id="283" r:id="rId29"/>
+    <p:sldId id="284" r:id="rId30"/>
+    <p:sldId id="285" r:id="rId31"/>
+    <p:sldId id="286" r:id="rId32"/>
+    <p:sldId id="287" r:id="rId33"/>
   </p:sldIdLst>
-  <p:sldSz cx="12191695" cy="6858000" type="screen4x3"/>
+  <p:sldSz cx="12192000" cy="6858000"/>
   <p:notesSz cx="6858000" cy="9144000"/>
   <p:defaultTextStyle>
     <a:defPPr>
@@ -135,6 +135,22 @@
       </a:defRPr>
     </a:lvl9pPr>
   </p:defaultTextStyle>
+  <p:extLst>
+    <p:ext uri="{EFAFB233-063F-42B5-8137-9DF3F51BA10A}">
+      <p15:sldGuideLst xmlns:p15="http://schemas.microsoft.com/office/powerpoint/2012/main">
+        <p15:guide id="1" orient="horz" pos="2160">
+          <p15:clr>
+            <a:srgbClr val="A4A3A4"/>
+          </p15:clr>
+        </p15:guide>
+        <p15:guide id="2" pos="2880">
+          <p15:clr>
+            <a:srgbClr val="A4A3A4"/>
+          </p15:clr>
+        </p15:guide>
+      </p15:sldGuideLst>
+    </p:ext>
+  </p:extLst>
 </p:presentation>
 </file>
 
@@ -176,10 +192,9 @@
           <a:lstStyle/>
           <a:p>
             <a:r>
-              <a:rPr lang="en-US" smtClean="0"/>
+              <a:rPr lang="en-US"/>
               <a:t>Click to edit Master title style</a:t>
             </a:r>
-            <a:endParaRPr lang="en-US"/>
           </a:p>
         </p:txBody>
       </p:sp>
@@ -295,10 +310,9 @@
           </a:lstStyle>
           <a:p>
             <a:r>
-              <a:rPr lang="en-US" smtClean="0"/>
+              <a:rPr lang="en-US"/>
               <a:t>Click to edit Master subtitle style</a:t>
             </a:r>
-            <a:endParaRPr lang="en-US"/>
           </a:p>
         </p:txBody>
       </p:sp>
@@ -319,7 +333,7 @@
           <a:p>
             <a:fld id="{5BCAD085-E8A6-8845-BD4E-CB4CCA059FC4}" type="datetimeFigureOut">
               <a:rPr lang="en-US" smtClean="0"/>
-              <a:t>1/27/13</a:t>
+              <a:t>4/16/26</a:t>
             </a:fld>
             <a:endParaRPr lang="en-US"/>
           </a:p>
@@ -413,10 +427,9 @@
           <a:lstStyle/>
           <a:p>
             <a:r>
-              <a:rPr lang="en-US" smtClean="0"/>
+              <a:rPr lang="en-US"/>
               <a:t>Click to edit Master title style</a:t>
             </a:r>
-            <a:endParaRPr lang="en-US"/>
           </a:p>
         </p:txBody>
       </p:sp>
@@ -437,38 +450,37 @@
           <a:p>
             <a:pPr lvl="0"/>
             <a:r>
-              <a:rPr lang="en-US" smtClean="0"/>
+              <a:rPr lang="en-US"/>
               <a:t>Click to edit Master text styles</a:t>
             </a:r>
           </a:p>
           <a:p>
             <a:pPr lvl="1"/>
             <a:r>
-              <a:rPr lang="en-US" smtClean="0"/>
+              <a:rPr lang="en-US"/>
               <a:t>Second level</a:t>
             </a:r>
           </a:p>
           <a:p>
             <a:pPr lvl="2"/>
             <a:r>
-              <a:rPr lang="en-US" smtClean="0"/>
+              <a:rPr lang="en-US"/>
               <a:t>Third level</a:t>
             </a:r>
           </a:p>
           <a:p>
             <a:pPr lvl="3"/>
             <a:r>
-              <a:rPr lang="en-US" smtClean="0"/>
+              <a:rPr lang="en-US"/>
               <a:t>Fourth level</a:t>
             </a:r>
           </a:p>
           <a:p>
             <a:pPr lvl="4"/>
             <a:r>
-              <a:rPr lang="en-US" smtClean="0"/>
+              <a:rPr lang="en-US"/>
               <a:t>Fifth level</a:t>
             </a:r>
-            <a:endParaRPr lang="en-US"/>
           </a:p>
         </p:txBody>
       </p:sp>
@@ -489,7 +501,7 @@
           <a:p>
             <a:fld id="{5BCAD085-E8A6-8845-BD4E-CB4CCA059FC4}" type="datetimeFigureOut">
               <a:rPr lang="en-US" smtClean="0"/>
-              <a:t>1/27/13</a:t>
+              <a:t>4/16/26</a:t>
             </a:fld>
             <a:endParaRPr lang="en-US"/>
           </a:p>
@@ -588,10 +600,9 @@
           <a:lstStyle/>
           <a:p>
             <a:r>
-              <a:rPr lang="en-US" smtClean="0"/>
+              <a:rPr lang="en-US"/>
               <a:t>Click to edit Master title style</a:t>
             </a:r>
-            <a:endParaRPr lang="en-US"/>
           </a:p>
         </p:txBody>
       </p:sp>
@@ -617,38 +628,37 @@
           <a:p>
             <a:pPr lvl="0"/>
             <a:r>
-              <a:rPr lang="en-US" smtClean="0"/>
+              <a:rPr lang="en-US"/>
               <a:t>Click to edit Master text styles</a:t>
             </a:r>
           </a:p>
           <a:p>
             <a:pPr lvl="1"/>
             <a:r>
-              <a:rPr lang="en-US" smtClean="0"/>
+              <a:rPr lang="en-US"/>
               <a:t>Second level</a:t>
             </a:r>
           </a:p>
           <a:p>
             <a:pPr lvl="2"/>
             <a:r>
-              <a:rPr lang="en-US" smtClean="0"/>
+              <a:rPr lang="en-US"/>
               <a:t>Third level</a:t>
             </a:r>
           </a:p>
           <a:p>
             <a:pPr lvl="3"/>
             <a:r>
-              <a:rPr lang="en-US" smtClean="0"/>
+              <a:rPr lang="en-US"/>
               <a:t>Fourth level</a:t>
             </a:r>
           </a:p>
           <a:p>
             <a:pPr lvl="4"/>
             <a:r>
-              <a:rPr lang="en-US" smtClean="0"/>
+              <a:rPr lang="en-US"/>
               <a:t>Fifth level</a:t>
             </a:r>
-            <a:endParaRPr lang="en-US"/>
           </a:p>
         </p:txBody>
       </p:sp>
@@ -669,7 +679,7 @@
           <a:p>
             <a:fld id="{5BCAD085-E8A6-8845-BD4E-CB4CCA059FC4}" type="datetimeFigureOut">
               <a:rPr lang="en-US" smtClean="0"/>
-              <a:t>1/27/13</a:t>
+              <a:t>4/16/26</a:t>
             </a:fld>
             <a:endParaRPr lang="en-US"/>
           </a:p>
@@ -763,10 +773,9 @@
           <a:lstStyle/>
           <a:p>
             <a:r>
-              <a:rPr lang="en-US" smtClean="0"/>
+              <a:rPr lang="en-US"/>
               <a:t>Click to edit Master title style</a:t>
             </a:r>
-            <a:endParaRPr lang="en-US"/>
           </a:p>
         </p:txBody>
       </p:sp>
@@ -787,38 +796,37 @@
           <a:p>
             <a:pPr lvl="0"/>
             <a:r>
-              <a:rPr lang="en-US" smtClean="0"/>
+              <a:rPr lang="en-US"/>
               <a:t>Click to edit Master text styles</a:t>
             </a:r>
           </a:p>
           <a:p>
             <a:pPr lvl="1"/>
             <a:r>
-              <a:rPr lang="en-US" smtClean="0"/>
+              <a:rPr lang="en-US"/>
               <a:t>Second level</a:t>
             </a:r>
           </a:p>
           <a:p>
             <a:pPr lvl="2"/>
             <a:r>
-              <a:rPr lang="en-US" smtClean="0"/>
+              <a:rPr lang="en-US"/>
               <a:t>Third level</a:t>
             </a:r>
           </a:p>
           <a:p>
             <a:pPr lvl="3"/>
             <a:r>
-              <a:rPr lang="en-US" smtClean="0"/>
+              <a:rPr lang="en-US"/>
               <a:t>Fourth level</a:t>
             </a:r>
           </a:p>
           <a:p>
             <a:pPr lvl="4"/>
             <a:r>
-              <a:rPr lang="en-US" smtClean="0"/>
+              <a:rPr lang="en-US"/>
               <a:t>Fifth level</a:t>
             </a:r>
-            <a:endParaRPr lang="en-US"/>
           </a:p>
         </p:txBody>
       </p:sp>
@@ -839,7 +847,7 @@
           <a:p>
             <a:fld id="{5BCAD085-E8A6-8845-BD4E-CB4CCA059FC4}" type="datetimeFigureOut">
               <a:rPr lang="en-US" smtClean="0"/>
-              <a:t>1/27/13</a:t>
+              <a:t>4/16/26</a:t>
             </a:fld>
             <a:endParaRPr lang="en-US"/>
           </a:p>
@@ -942,10 +950,9 @@
           </a:lstStyle>
           <a:p>
             <a:r>
-              <a:rPr lang="en-US" smtClean="0"/>
+              <a:rPr lang="en-US"/>
               <a:t>Click to edit Master title style</a:t>
             </a:r>
-            <a:endParaRPr lang="en-US"/>
           </a:p>
         </p:txBody>
       </p:sp>
@@ -1062,7 +1069,7 @@
           <a:p>
             <a:pPr lvl="0"/>
             <a:r>
-              <a:rPr lang="en-US" smtClean="0"/>
+              <a:rPr lang="en-US"/>
               <a:t>Click to edit Master text styles</a:t>
             </a:r>
           </a:p>
@@ -1085,7 +1092,7 @@
           <a:p>
             <a:fld id="{5BCAD085-E8A6-8845-BD4E-CB4CCA059FC4}" type="datetimeFigureOut">
               <a:rPr lang="en-US" smtClean="0"/>
-              <a:t>1/27/13</a:t>
+              <a:t>4/16/26</a:t>
             </a:fld>
             <a:endParaRPr lang="en-US"/>
           </a:p>
@@ -1179,10 +1186,9 @@
           <a:lstStyle/>
           <a:p>
             <a:r>
-              <a:rPr lang="en-US" smtClean="0"/>
+              <a:rPr lang="en-US"/>
               <a:t>Click to edit Master title style</a:t>
             </a:r>
-            <a:endParaRPr lang="en-US"/>
           </a:p>
         </p:txBody>
       </p:sp>
@@ -1236,38 +1242,37 @@
           <a:p>
             <a:pPr lvl="0"/>
             <a:r>
-              <a:rPr lang="en-US" smtClean="0"/>
+              <a:rPr lang="en-US"/>
               <a:t>Click to edit Master text styles</a:t>
             </a:r>
           </a:p>
           <a:p>
             <a:pPr lvl="1"/>
             <a:r>
-              <a:rPr lang="en-US" smtClean="0"/>
+              <a:rPr lang="en-US"/>
               <a:t>Second level</a:t>
             </a:r>
           </a:p>
           <a:p>
             <a:pPr lvl="2"/>
             <a:r>
-              <a:rPr lang="en-US" smtClean="0"/>
+              <a:rPr lang="en-US"/>
               <a:t>Third level</a:t>
             </a:r>
           </a:p>
           <a:p>
             <a:pPr lvl="3"/>
             <a:r>
-              <a:rPr lang="en-US" smtClean="0"/>
+              <a:rPr lang="en-US"/>
               <a:t>Fourth level</a:t>
             </a:r>
           </a:p>
           <a:p>
             <a:pPr lvl="4"/>
             <a:r>
-              <a:rPr lang="en-US" smtClean="0"/>
+              <a:rPr lang="en-US"/>
               <a:t>Fifth level</a:t>
             </a:r>
-            <a:endParaRPr lang="en-US"/>
           </a:p>
         </p:txBody>
       </p:sp>
@@ -1321,38 +1326,37 @@
           <a:p>
             <a:pPr lvl="0"/>
             <a:r>
-              <a:rPr lang="en-US" smtClean="0"/>
+              <a:rPr lang="en-US"/>
               <a:t>Click to edit Master text styles</a:t>
             </a:r>
           </a:p>
           <a:p>
             <a:pPr lvl="1"/>
             <a:r>
-              <a:rPr lang="en-US" smtClean="0"/>
+              <a:rPr lang="en-US"/>
               <a:t>Second level</a:t>
             </a:r>
           </a:p>
           <a:p>
             <a:pPr lvl="2"/>
             <a:r>
-              <a:rPr lang="en-US" smtClean="0"/>
+              <a:rPr lang="en-US"/>
               <a:t>Third level</a:t>
             </a:r>
           </a:p>
           <a:p>
             <a:pPr lvl="3"/>
             <a:r>
-              <a:rPr lang="en-US" smtClean="0"/>
+              <a:rPr lang="en-US"/>
               <a:t>Fourth level</a:t>
             </a:r>
           </a:p>
           <a:p>
             <a:pPr lvl="4"/>
             <a:r>
-              <a:rPr lang="en-US" smtClean="0"/>
+              <a:rPr lang="en-US"/>
               <a:t>Fifth level</a:t>
             </a:r>
-            <a:endParaRPr lang="en-US"/>
           </a:p>
         </p:txBody>
       </p:sp>
@@ -1373,7 +1377,7 @@
           <a:p>
             <a:fld id="{5BCAD085-E8A6-8845-BD4E-CB4CCA059FC4}" type="datetimeFigureOut">
               <a:rPr lang="en-US" smtClean="0"/>
-              <a:t>1/27/13</a:t>
+              <a:t>4/16/26</a:t>
             </a:fld>
             <a:endParaRPr lang="en-US"/>
           </a:p>
@@ -1471,10 +1475,9 @@
           </a:lstStyle>
           <a:p>
             <a:r>
-              <a:rPr lang="en-US" smtClean="0"/>
+              <a:rPr lang="en-US"/>
               <a:t>Click to edit Master title style</a:t>
             </a:r>
-            <a:endParaRPr lang="en-US"/>
           </a:p>
         </p:txBody>
       </p:sp>
@@ -1537,7 +1540,7 @@
           <a:p>
             <a:pPr lvl="0"/>
             <a:r>
-              <a:rPr lang="en-US" smtClean="0"/>
+              <a:rPr lang="en-US"/>
               <a:t>Click to edit Master text styles</a:t>
             </a:r>
           </a:p>
@@ -1593,38 +1596,37 @@
           <a:p>
             <a:pPr lvl="0"/>
             <a:r>
-              <a:rPr lang="en-US" smtClean="0"/>
+              <a:rPr lang="en-US"/>
               <a:t>Click to edit Master text styles</a:t>
             </a:r>
           </a:p>
           <a:p>
             <a:pPr lvl="1"/>
             <a:r>
-              <a:rPr lang="en-US" smtClean="0"/>
+              <a:rPr lang="en-US"/>
               <a:t>Second level</a:t>
             </a:r>
           </a:p>
           <a:p>
             <a:pPr lvl="2"/>
             <a:r>
-              <a:rPr lang="en-US" smtClean="0"/>
+              <a:rPr lang="en-US"/>
               <a:t>Third level</a:t>
             </a:r>
           </a:p>
           <a:p>
             <a:pPr lvl="3"/>
             <a:r>
-              <a:rPr lang="en-US" smtClean="0"/>
+              <a:rPr lang="en-US"/>
               <a:t>Fourth level</a:t>
             </a:r>
           </a:p>
           <a:p>
             <a:pPr lvl="4"/>
             <a:r>
-              <a:rPr lang="en-US" smtClean="0"/>
+              <a:rPr lang="en-US"/>
               <a:t>Fifth level</a:t>
             </a:r>
-            <a:endParaRPr lang="en-US"/>
           </a:p>
         </p:txBody>
       </p:sp>
@@ -1687,7 +1689,7 @@
           <a:p>
             <a:pPr lvl="0"/>
             <a:r>
-              <a:rPr lang="en-US" smtClean="0"/>
+              <a:rPr lang="en-US"/>
               <a:t>Click to edit Master text styles</a:t>
             </a:r>
           </a:p>
@@ -1743,38 +1745,37 @@
           <a:p>
             <a:pPr lvl="0"/>
             <a:r>
-              <a:rPr lang="en-US" smtClean="0"/>
+              <a:rPr lang="en-US"/>
               <a:t>Click to edit Master text styles</a:t>
             </a:r>
           </a:p>
           <a:p>
             <a:pPr lvl="1"/>
             <a:r>
-              <a:rPr lang="en-US" smtClean="0"/>
+              <a:rPr lang="en-US"/>
               <a:t>Second level</a:t>
             </a:r>
           </a:p>
           <a:p>
             <a:pPr lvl="2"/>
             <a:r>
-              <a:rPr lang="en-US" smtClean="0"/>
+              <a:rPr lang="en-US"/>
               <a:t>Third level</a:t>
             </a:r>
           </a:p>
           <a:p>
             <a:pPr lvl="3"/>
             <a:r>
-              <a:rPr lang="en-US" smtClean="0"/>
+              <a:rPr lang="en-US"/>
               <a:t>Fourth level</a:t>
             </a:r>
           </a:p>
           <a:p>
             <a:pPr lvl="4"/>
             <a:r>
-              <a:rPr lang="en-US" smtClean="0"/>
+              <a:rPr lang="en-US"/>
               <a:t>Fifth level</a:t>
             </a:r>
-            <a:endParaRPr lang="en-US"/>
           </a:p>
         </p:txBody>
       </p:sp>
@@ -1795,7 +1796,7 @@
           <a:p>
             <a:fld id="{5BCAD085-E8A6-8845-BD4E-CB4CCA059FC4}" type="datetimeFigureOut">
               <a:rPr lang="en-US" smtClean="0"/>
-              <a:t>1/27/13</a:t>
+              <a:t>4/16/26</a:t>
             </a:fld>
             <a:endParaRPr lang="en-US"/>
           </a:p>
@@ -1889,10 +1890,9 @@
           <a:lstStyle/>
           <a:p>
             <a:r>
-              <a:rPr lang="en-US" smtClean="0"/>
+              <a:rPr lang="en-US"/>
               <a:t>Click to edit Master title style</a:t>
             </a:r>
-            <a:endParaRPr lang="en-US"/>
           </a:p>
         </p:txBody>
       </p:sp>
@@ -1913,7 +1913,7 @@
           <a:p>
             <a:fld id="{5BCAD085-E8A6-8845-BD4E-CB4CCA059FC4}" type="datetimeFigureOut">
               <a:rPr lang="en-US" smtClean="0"/>
-              <a:t>1/27/13</a:t>
+              <a:t>4/16/26</a:t>
             </a:fld>
             <a:endParaRPr lang="en-US"/>
           </a:p>
@@ -2008,7 +2008,7 @@
           <a:p>
             <a:fld id="{5BCAD085-E8A6-8845-BD4E-CB4CCA059FC4}" type="datetimeFigureOut">
               <a:rPr lang="en-US" smtClean="0"/>
-              <a:t>1/27/13</a:t>
+              <a:t>4/16/26</a:t>
             </a:fld>
             <a:endParaRPr lang="en-US"/>
           </a:p>
@@ -2111,10 +2111,9 @@
           </a:lstStyle>
           <a:p>
             <a:r>
-              <a:rPr lang="en-US" smtClean="0"/>
+              <a:rPr lang="en-US"/>
               <a:t>Click to edit Master title style</a:t>
             </a:r>
-            <a:endParaRPr lang="en-US"/>
           </a:p>
         </p:txBody>
       </p:sp>
@@ -2168,38 +2167,37 @@
           <a:p>
             <a:pPr lvl="0"/>
             <a:r>
-              <a:rPr lang="en-US" smtClean="0"/>
+              <a:rPr lang="en-US"/>
               <a:t>Click to edit Master text styles</a:t>
             </a:r>
           </a:p>
           <a:p>
             <a:pPr lvl="1"/>
             <a:r>
-              <a:rPr lang="en-US" smtClean="0"/>
+              <a:rPr lang="en-US"/>
               <a:t>Second level</a:t>
             </a:r>
           </a:p>
           <a:p>
             <a:pPr lvl="2"/>
             <a:r>
-              <a:rPr lang="en-US" smtClean="0"/>
+              <a:rPr lang="en-US"/>
               <a:t>Third level</a:t>
             </a:r>
           </a:p>
           <a:p>
             <a:pPr lvl="3"/>
             <a:r>
-              <a:rPr lang="en-US" smtClean="0"/>
+              <a:rPr lang="en-US"/>
               <a:t>Fourth level</a:t>
             </a:r>
           </a:p>
           <a:p>
             <a:pPr lvl="4"/>
             <a:r>
-              <a:rPr lang="en-US" smtClean="0"/>
+              <a:rPr lang="en-US"/>
               <a:t>Fifth level</a:t>
             </a:r>
-            <a:endParaRPr lang="en-US"/>
           </a:p>
         </p:txBody>
       </p:sp>
@@ -2262,7 +2260,7 @@
           <a:p>
             <a:pPr lvl="0"/>
             <a:r>
-              <a:rPr lang="en-US" smtClean="0"/>
+              <a:rPr lang="en-US"/>
               <a:t>Click to edit Master text styles</a:t>
             </a:r>
           </a:p>
@@ -2285,7 +2283,7 @@
           <a:p>
             <a:fld id="{5BCAD085-E8A6-8845-BD4E-CB4CCA059FC4}" type="datetimeFigureOut">
               <a:rPr lang="en-US" smtClean="0"/>
-              <a:t>1/27/13</a:t>
+              <a:t>4/16/26</a:t>
             </a:fld>
             <a:endParaRPr lang="en-US"/>
           </a:p>
@@ -2388,10 +2386,9 @@
           </a:lstStyle>
           <a:p>
             <a:r>
-              <a:rPr lang="en-US" smtClean="0"/>
+              <a:rPr lang="en-US"/>
               <a:t>Click to edit Master title style</a:t>
             </a:r>
-            <a:endParaRPr lang="en-US"/>
           </a:p>
         </p:txBody>
       </p:sp>
@@ -2515,7 +2512,7 @@
           <a:p>
             <a:pPr lvl="0"/>
             <a:r>
-              <a:rPr lang="en-US" smtClean="0"/>
+              <a:rPr lang="en-US"/>
               <a:t>Click to edit Master text styles</a:t>
             </a:r>
           </a:p>
@@ -2538,7 +2535,7 @@
           <a:p>
             <a:fld id="{5BCAD085-E8A6-8845-BD4E-CB4CCA059FC4}" type="datetimeFigureOut">
               <a:rPr lang="en-US" smtClean="0"/>
-              <a:t>1/27/13</a:t>
+              <a:t>4/16/26</a:t>
             </a:fld>
             <a:endParaRPr lang="en-US"/>
           </a:p>
@@ -2647,10 +2644,9 @@
           <a:lstStyle/>
           <a:p>
             <a:r>
-              <a:rPr lang="en-US" smtClean="0"/>
+              <a:rPr lang="en-US"/>
               <a:t>Click to edit Master title style</a:t>
             </a:r>
-            <a:endParaRPr lang="en-US"/>
           </a:p>
         </p:txBody>
       </p:sp>
@@ -2681,38 +2677,37 @@
           <a:p>
             <a:pPr lvl="0"/>
             <a:r>
-              <a:rPr lang="en-US" smtClean="0"/>
+              <a:rPr lang="en-US"/>
               <a:t>Click to edit Master text styles</a:t>
             </a:r>
           </a:p>
           <a:p>
             <a:pPr lvl="1"/>
             <a:r>
-              <a:rPr lang="en-US" smtClean="0"/>
+              <a:rPr lang="en-US"/>
               <a:t>Second level</a:t>
             </a:r>
           </a:p>
           <a:p>
             <a:pPr lvl="2"/>
             <a:r>
-              <a:rPr lang="en-US" smtClean="0"/>
+              <a:rPr lang="en-US"/>
               <a:t>Third level</a:t>
             </a:r>
           </a:p>
           <a:p>
             <a:pPr lvl="3"/>
             <a:r>
-              <a:rPr lang="en-US" smtClean="0"/>
+              <a:rPr lang="en-US"/>
               <a:t>Fourth level</a:t>
             </a:r>
           </a:p>
           <a:p>
             <a:pPr lvl="4"/>
             <a:r>
-              <a:rPr lang="en-US" smtClean="0"/>
+              <a:rPr lang="en-US"/>
               <a:t>Fifth level</a:t>
             </a:r>
-            <a:endParaRPr lang="en-US"/>
           </a:p>
         </p:txBody>
       </p:sp>
@@ -2751,7 +2746,7 @@
           <a:p>
             <a:fld id="{5BCAD085-E8A6-8845-BD4E-CB4CCA059FC4}" type="datetimeFigureOut">
               <a:rPr lang="en-US" smtClean="0"/>
-              <a:t>1/27/13</a:t>
+              <a:t>4/16/26</a:t>
             </a:fld>
             <a:endParaRPr lang="en-US"/>
           </a:p>
@@ -3110,7 +3105,7 @@
 </file>
 
 <file path=ppt/slides/slide1.xml><?xml version="1.0" encoding="utf-8"?>
-<p:sld xmlns:a="http://schemas.openxmlformats.org/drawingml/2006/main" xmlns:p="http://schemas.openxmlformats.org/presentationml/2006/main" xmlns:r="http://schemas.openxmlformats.org/officeDocument/2006/relationships">
+<p:sld xmlns:a="http://schemas.openxmlformats.org/drawingml/2006/main" xmlns:r="http://schemas.openxmlformats.org/officeDocument/2006/relationships" xmlns:p="http://schemas.openxmlformats.org/presentationml/2006/main">
   <p:cSld>
     <p:bg>
       <p:bgPr>
@@ -3126,7 +3121,14 @@
         <p:cNvGrpSpPr/>
         <p:nvPr/>
       </p:nvGrpSpPr>
-      <p:grpSpPr/>
+      <p:grpSpPr>
+        <a:xfrm>
+          <a:off x="0" y="0"/>
+          <a:ext cx="0" cy="0"/>
+          <a:chOff x="0" y="0"/>
+          <a:chExt cx="0" cy="0"/>
+        </a:xfrm>
+      </p:grpSpPr>
       <p:sp>
         <p:nvSpPr>
           <p:cNvPr id="2" name="Rectangle 1"/>
@@ -3167,6 +3169,7 @@
           <a:lstStyle/>
           <a:p>
             <a:pPr algn="ctr"/>
+            <a:endParaRPr/>
           </a:p>
         </p:txBody>
       </p:sp>
@@ -3210,6 +3213,7 @@
           <a:lstStyle/>
           <a:p>
             <a:pPr algn="ctr"/>
+            <a:endParaRPr/>
           </a:p>
         </p:txBody>
       </p:sp>
@@ -3253,6 +3257,7 @@
           <a:lstStyle/>
           <a:p>
             <a:pPr algn="ctr"/>
+            <a:endParaRPr/>
           </a:p>
         </p:txBody>
       </p:sp>
@@ -3296,6 +3301,7 @@
           <a:lstStyle/>
           <a:p>
             <a:pPr algn="ctr"/>
+            <a:endParaRPr/>
           </a:p>
         </p:txBody>
       </p:sp>
@@ -3339,6 +3345,7 @@
           <a:lstStyle/>
           <a:p>
             <a:pPr algn="ctr"/>
+            <a:endParaRPr/>
           </a:p>
         </p:txBody>
       </p:sp>
@@ -3382,6 +3389,7 @@
           <a:lstStyle/>
           <a:p>
             <a:pPr algn="ctr"/>
+            <a:endParaRPr/>
           </a:p>
         </p:txBody>
       </p:sp>
@@ -3586,7 +3594,7 @@
 </file>
 
 <file path=ppt/slides/slide10.xml><?xml version="1.0" encoding="utf-8"?>
-<p:sld xmlns:a="http://schemas.openxmlformats.org/drawingml/2006/main" xmlns:p="http://schemas.openxmlformats.org/presentationml/2006/main" xmlns:r="http://schemas.openxmlformats.org/officeDocument/2006/relationships">
+<p:sld xmlns:a="http://schemas.openxmlformats.org/drawingml/2006/main" xmlns:r="http://schemas.openxmlformats.org/officeDocument/2006/relationships" xmlns:p="http://schemas.openxmlformats.org/presentationml/2006/main">
   <p:cSld>
     <p:bg>
       <p:bgPr>
@@ -3602,7 +3610,14 @@
         <p:cNvGrpSpPr/>
         <p:nvPr/>
       </p:nvGrpSpPr>
-      <p:grpSpPr/>
+      <p:grpSpPr>
+        <a:xfrm>
+          <a:off x="0" y="0"/>
+          <a:ext cx="0" cy="0"/>
+          <a:chOff x="0" y="0"/>
+          <a:chExt cx="0" cy="0"/>
+        </a:xfrm>
+      </p:grpSpPr>
       <p:sp>
         <p:nvSpPr>
           <p:cNvPr id="2" name="Rectangle 1"/>
@@ -3643,6 +3658,7 @@
           <a:lstStyle/>
           <a:p>
             <a:pPr algn="ctr"/>
+            <a:endParaRPr/>
           </a:p>
         </p:txBody>
       </p:sp>
@@ -3823,7 +3839,7 @@
 </file>
 
 <file path=ppt/slides/slide11.xml><?xml version="1.0" encoding="utf-8"?>
-<p:sld xmlns:a="http://schemas.openxmlformats.org/drawingml/2006/main" xmlns:p="http://schemas.openxmlformats.org/presentationml/2006/main" xmlns:r="http://schemas.openxmlformats.org/officeDocument/2006/relationships">
+<p:sld xmlns:a="http://schemas.openxmlformats.org/drawingml/2006/main" xmlns:r="http://schemas.openxmlformats.org/officeDocument/2006/relationships" xmlns:p="http://schemas.openxmlformats.org/presentationml/2006/main">
   <p:cSld>
     <p:bg>
       <p:bgPr>
@@ -3839,7 +3855,14 @@
         <p:cNvGrpSpPr/>
         <p:nvPr/>
       </p:nvGrpSpPr>
-      <p:grpSpPr/>
+      <p:grpSpPr>
+        <a:xfrm>
+          <a:off x="0" y="0"/>
+          <a:ext cx="0" cy="0"/>
+          <a:chOff x="0" y="0"/>
+          <a:chExt cx="0" cy="0"/>
+        </a:xfrm>
+      </p:grpSpPr>
       <p:sp>
         <p:nvSpPr>
           <p:cNvPr id="2" name="Rectangle 1"/>
@@ -3880,6 +3903,7 @@
           <a:lstStyle/>
           <a:p>
             <a:pPr algn="ctr"/>
+            <a:endParaRPr/>
           </a:p>
         </p:txBody>
       </p:sp>
@@ -4060,7 +4084,7 @@
 </file>
 
 <file path=ppt/slides/slide12.xml><?xml version="1.0" encoding="utf-8"?>
-<p:sld xmlns:a="http://schemas.openxmlformats.org/drawingml/2006/main" xmlns:p="http://schemas.openxmlformats.org/presentationml/2006/main" xmlns:r="http://schemas.openxmlformats.org/officeDocument/2006/relationships">
+<p:sld xmlns:a="http://schemas.openxmlformats.org/drawingml/2006/main" xmlns:r="http://schemas.openxmlformats.org/officeDocument/2006/relationships" xmlns:p="http://schemas.openxmlformats.org/presentationml/2006/main">
   <p:cSld>
     <p:bg>
       <p:bgPr>
@@ -4076,7 +4100,14 @@
         <p:cNvGrpSpPr/>
         <p:nvPr/>
       </p:nvGrpSpPr>
-      <p:grpSpPr/>
+      <p:grpSpPr>
+        <a:xfrm>
+          <a:off x="0" y="0"/>
+          <a:ext cx="0" cy="0"/>
+          <a:chOff x="0" y="0"/>
+          <a:chExt cx="0" cy="0"/>
+        </a:xfrm>
+      </p:grpSpPr>
       <p:sp>
         <p:nvSpPr>
           <p:cNvPr id="2" name="Rectangle 1"/>
@@ -4117,6 +4148,7 @@
           <a:lstStyle/>
           <a:p>
             <a:pPr algn="ctr"/>
+            <a:endParaRPr/>
           </a:p>
         </p:txBody>
       </p:sp>
@@ -4333,7 +4365,7 @@
 </file>
 
 <file path=ppt/slides/slide13.xml><?xml version="1.0" encoding="utf-8"?>
-<p:sld xmlns:a="http://schemas.openxmlformats.org/drawingml/2006/main" xmlns:p="http://schemas.openxmlformats.org/presentationml/2006/main" xmlns:r="http://schemas.openxmlformats.org/officeDocument/2006/relationships">
+<p:sld xmlns:a="http://schemas.openxmlformats.org/drawingml/2006/main" xmlns:r="http://schemas.openxmlformats.org/officeDocument/2006/relationships" xmlns:p="http://schemas.openxmlformats.org/presentationml/2006/main">
   <p:cSld>
     <p:bg>
       <p:bgPr>
@@ -4349,7 +4381,14 @@
         <p:cNvGrpSpPr/>
         <p:nvPr/>
       </p:nvGrpSpPr>
-      <p:grpSpPr/>
+      <p:grpSpPr>
+        <a:xfrm>
+          <a:off x="0" y="0"/>
+          <a:ext cx="0" cy="0"/>
+          <a:chOff x="0" y="0"/>
+          <a:chExt cx="0" cy="0"/>
+        </a:xfrm>
+      </p:grpSpPr>
       <p:sp>
         <p:nvSpPr>
           <p:cNvPr id="2" name="Rectangle 1"/>
@@ -4390,6 +4429,7 @@
           <a:lstStyle/>
           <a:p>
             <a:pPr algn="ctr"/>
+            <a:endParaRPr/>
           </a:p>
         </p:txBody>
       </p:sp>
@@ -4570,7 +4610,7 @@
 </file>
 
 <file path=ppt/slides/slide14.xml><?xml version="1.0" encoding="utf-8"?>
-<p:sld xmlns:a="http://schemas.openxmlformats.org/drawingml/2006/main" xmlns:p="http://schemas.openxmlformats.org/presentationml/2006/main" xmlns:r="http://schemas.openxmlformats.org/officeDocument/2006/relationships">
+<p:sld xmlns:a="http://schemas.openxmlformats.org/drawingml/2006/main" xmlns:r="http://schemas.openxmlformats.org/officeDocument/2006/relationships" xmlns:p="http://schemas.openxmlformats.org/presentationml/2006/main">
   <p:cSld>
     <p:bg>
       <p:bgPr>
@@ -4586,7 +4626,14 @@
         <p:cNvGrpSpPr/>
         <p:nvPr/>
       </p:nvGrpSpPr>
-      <p:grpSpPr/>
+      <p:grpSpPr>
+        <a:xfrm>
+          <a:off x="0" y="0"/>
+          <a:ext cx="0" cy="0"/>
+          <a:chOff x="0" y="0"/>
+          <a:chExt cx="0" cy="0"/>
+        </a:xfrm>
+      </p:grpSpPr>
       <p:sp>
         <p:nvSpPr>
           <p:cNvPr id="2" name="Rectangle 1"/>
@@ -4627,6 +4674,7 @@
           <a:lstStyle/>
           <a:p>
             <a:pPr algn="ctr"/>
+            <a:endParaRPr/>
           </a:p>
         </p:txBody>
       </p:sp>
@@ -4807,7 +4855,7 @@
 </file>
 
 <file path=ppt/slides/slide15.xml><?xml version="1.0" encoding="utf-8"?>
-<p:sld xmlns:a="http://schemas.openxmlformats.org/drawingml/2006/main" xmlns:p="http://schemas.openxmlformats.org/presentationml/2006/main" xmlns:r="http://schemas.openxmlformats.org/officeDocument/2006/relationships">
+<p:sld xmlns:a="http://schemas.openxmlformats.org/drawingml/2006/main" xmlns:r="http://schemas.openxmlformats.org/officeDocument/2006/relationships" xmlns:p="http://schemas.openxmlformats.org/presentationml/2006/main">
   <p:cSld>
     <p:bg>
       <p:bgPr>
@@ -4823,7 +4871,14 @@
         <p:cNvGrpSpPr/>
         <p:nvPr/>
       </p:nvGrpSpPr>
-      <p:grpSpPr/>
+      <p:grpSpPr>
+        <a:xfrm>
+          <a:off x="0" y="0"/>
+          <a:ext cx="0" cy="0"/>
+          <a:chOff x="0" y="0"/>
+          <a:chExt cx="0" cy="0"/>
+        </a:xfrm>
+      </p:grpSpPr>
       <p:sp>
         <p:nvSpPr>
           <p:cNvPr id="2" name="Rectangle 1"/>
@@ -4864,6 +4919,7 @@
           <a:lstStyle/>
           <a:p>
             <a:pPr algn="ctr"/>
+            <a:endParaRPr/>
           </a:p>
         </p:txBody>
       </p:sp>
@@ -5044,7 +5100,7 @@
 </file>
 
 <file path=ppt/slides/slide16.xml><?xml version="1.0" encoding="utf-8"?>
-<p:sld xmlns:a="http://schemas.openxmlformats.org/drawingml/2006/main" xmlns:p="http://schemas.openxmlformats.org/presentationml/2006/main" xmlns:r="http://schemas.openxmlformats.org/officeDocument/2006/relationships">
+<p:sld xmlns:a="http://schemas.openxmlformats.org/drawingml/2006/main" xmlns:r="http://schemas.openxmlformats.org/officeDocument/2006/relationships" xmlns:p="http://schemas.openxmlformats.org/presentationml/2006/main">
   <p:cSld>
     <p:bg>
       <p:bgPr>
@@ -5060,7 +5116,14 @@
         <p:cNvGrpSpPr/>
         <p:nvPr/>
       </p:nvGrpSpPr>
-      <p:grpSpPr/>
+      <p:grpSpPr>
+        <a:xfrm>
+          <a:off x="0" y="0"/>
+          <a:ext cx="0" cy="0"/>
+          <a:chOff x="0" y="0"/>
+          <a:chExt cx="0" cy="0"/>
+        </a:xfrm>
+      </p:grpSpPr>
       <p:sp>
         <p:nvSpPr>
           <p:cNvPr id="2" name="Rectangle 1"/>
@@ -5101,6 +5164,7 @@
           <a:lstStyle/>
           <a:p>
             <a:pPr algn="ctr"/>
+            <a:endParaRPr/>
           </a:p>
         </p:txBody>
       </p:sp>
@@ -5360,7 +5424,7 @@
 </file>
 
 <file path=ppt/slides/slide17.xml><?xml version="1.0" encoding="utf-8"?>
-<p:sld xmlns:a="http://schemas.openxmlformats.org/drawingml/2006/main" xmlns:p="http://schemas.openxmlformats.org/presentationml/2006/main" xmlns:r="http://schemas.openxmlformats.org/officeDocument/2006/relationships">
+<p:sld xmlns:a="http://schemas.openxmlformats.org/drawingml/2006/main" xmlns:r="http://schemas.openxmlformats.org/officeDocument/2006/relationships" xmlns:p="http://schemas.openxmlformats.org/presentationml/2006/main">
   <p:cSld>
     <p:bg>
       <p:bgPr>
@@ -5376,7 +5440,14 @@
         <p:cNvGrpSpPr/>
         <p:nvPr/>
       </p:nvGrpSpPr>
-      <p:grpSpPr/>
+      <p:grpSpPr>
+        <a:xfrm>
+          <a:off x="0" y="0"/>
+          <a:ext cx="0" cy="0"/>
+          <a:chOff x="0" y="0"/>
+          <a:chExt cx="0" cy="0"/>
+        </a:xfrm>
+      </p:grpSpPr>
       <p:sp>
         <p:nvSpPr>
           <p:cNvPr id="2" name="Rectangle 1"/>
@@ -5417,6 +5488,7 @@
           <a:lstStyle/>
           <a:p>
             <a:pPr algn="ctr"/>
+            <a:endParaRPr/>
           </a:p>
         </p:txBody>
       </p:sp>
@@ -5500,7 +5572,7 @@
         </p:nvSpPr>
         <p:spPr>
           <a:xfrm>
-            <a:off x="731520" y="2103120"/>
+            <a:off x="731520" y="1623060"/>
             <a:ext cx="10515600" cy="2011680"/>
           </a:xfrm>
           <a:prstGeom prst="rect">
@@ -5536,7 +5608,7 @@
         </p:nvSpPr>
         <p:spPr>
           <a:xfrm>
-            <a:off x="731520" y="4206240"/>
+            <a:off x="731520" y="2788920"/>
             <a:ext cx="10515600" cy="320040"/>
           </a:xfrm>
           <a:prstGeom prst="rect">
@@ -5572,7 +5644,7 @@
         </p:nvSpPr>
         <p:spPr>
           <a:xfrm>
-            <a:off x="731520" y="4526280"/>
+            <a:off x="731520" y="3108960"/>
             <a:ext cx="10515600" cy="2103120"/>
           </a:xfrm>
           <a:prstGeom prst="rect">
@@ -5598,6 +5670,7 @@
               </a:defRPr>
             </a:pPr>
             <a:r>
+              <a:rPr dirty="0"/>
               <a:t>•  Too many steps for the time available</a:t>
             </a:r>
           </a:p>
@@ -5614,6 +5687,7 @@
               </a:defRPr>
             </a:pPr>
             <a:r>
+              <a:rPr dirty="0"/>
               <a:t>•  Instructions only make sense if YOU are there to explain them</a:t>
             </a:r>
           </a:p>
@@ -5630,6 +5704,7 @@
               </a:defRPr>
             </a:pPr>
             <a:r>
+              <a:rPr dirty="0"/>
               <a:t>•  No way for young people to make a real choice or give feedback</a:t>
             </a:r>
           </a:p>
@@ -5646,6 +5721,7 @@
               </a:defRPr>
             </a:pPr>
             <a:r>
+              <a:rPr dirty="0"/>
               <a:t>•  Only works on one device or one platform</a:t>
             </a:r>
           </a:p>
@@ -5662,6 +5738,7 @@
               </a:defRPr>
             </a:pPr>
             <a:r>
+              <a:rPr dirty="0"/>
               <a:t>•  Solves a problem the young people don't actually have</a:t>
             </a:r>
           </a:p>
@@ -5678,6 +5755,7 @@
               </a:defRPr>
             </a:pPr>
             <a:r>
+              <a:rPr dirty="0"/>
               <a:t>•  Would fall apart if 3 extra people joined or 3 people dropped out</a:t>
             </a:r>
           </a:p>
@@ -5752,7 +5830,7 @@
 </file>
 
 <file path=ppt/slides/slide18.xml><?xml version="1.0" encoding="utf-8"?>
-<p:sld xmlns:a="http://schemas.openxmlformats.org/drawingml/2006/main" xmlns:p="http://schemas.openxmlformats.org/presentationml/2006/main" xmlns:r="http://schemas.openxmlformats.org/officeDocument/2006/relationships">
+<p:sld xmlns:a="http://schemas.openxmlformats.org/drawingml/2006/main" xmlns:r="http://schemas.openxmlformats.org/officeDocument/2006/relationships" xmlns:p="http://schemas.openxmlformats.org/presentationml/2006/main">
   <p:cSld>
     <p:bg>
       <p:bgPr>
@@ -5768,7 +5846,14 @@
         <p:cNvGrpSpPr/>
         <p:nvPr/>
       </p:nvGrpSpPr>
-      <p:grpSpPr/>
+      <p:grpSpPr>
+        <a:xfrm>
+          <a:off x="0" y="0"/>
+          <a:ext cx="0" cy="0"/>
+          <a:chOff x="0" y="0"/>
+          <a:chExt cx="0" cy="0"/>
+        </a:xfrm>
+      </p:grpSpPr>
       <p:sp>
         <p:nvSpPr>
           <p:cNvPr id="2" name="Rectangle 1"/>
@@ -5809,6 +5894,7 @@
           <a:lstStyle/>
           <a:p>
             <a:pPr algn="ctr"/>
+            <a:endParaRPr/>
           </a:p>
         </p:txBody>
       </p:sp>
@@ -5989,7 +6075,7 @@
 </file>
 
 <file path=ppt/slides/slide19.xml><?xml version="1.0" encoding="utf-8"?>
-<p:sld xmlns:a="http://schemas.openxmlformats.org/drawingml/2006/main" xmlns:p="http://schemas.openxmlformats.org/presentationml/2006/main" xmlns:r="http://schemas.openxmlformats.org/officeDocument/2006/relationships">
+<p:sld xmlns:a="http://schemas.openxmlformats.org/drawingml/2006/main" xmlns:r="http://schemas.openxmlformats.org/officeDocument/2006/relationships" xmlns:p="http://schemas.openxmlformats.org/presentationml/2006/main">
   <p:cSld>
     <p:bg>
       <p:bgPr>
@@ -6005,7 +6091,14 @@
         <p:cNvGrpSpPr/>
         <p:nvPr/>
       </p:nvGrpSpPr>
-      <p:grpSpPr/>
+      <p:grpSpPr>
+        <a:xfrm>
+          <a:off x="0" y="0"/>
+          <a:ext cx="0" cy="0"/>
+          <a:chOff x="0" y="0"/>
+          <a:chExt cx="0" cy="0"/>
+        </a:xfrm>
+      </p:grpSpPr>
       <p:sp>
         <p:nvSpPr>
           <p:cNvPr id="2" name="Rectangle 1"/>
@@ -6046,6 +6139,7 @@
           <a:lstStyle/>
           <a:p>
             <a:pPr algn="ctr"/>
+            <a:endParaRPr/>
           </a:p>
         </p:txBody>
       </p:sp>
@@ -6262,7 +6356,7 @@
 </file>
 
 <file path=ppt/slides/slide2.xml><?xml version="1.0" encoding="utf-8"?>
-<p:sld xmlns:a="http://schemas.openxmlformats.org/drawingml/2006/main" xmlns:p="http://schemas.openxmlformats.org/presentationml/2006/main" xmlns:r="http://schemas.openxmlformats.org/officeDocument/2006/relationships">
+<p:sld xmlns:a="http://schemas.openxmlformats.org/drawingml/2006/main" xmlns:r="http://schemas.openxmlformats.org/officeDocument/2006/relationships" xmlns:p="http://schemas.openxmlformats.org/presentationml/2006/main">
   <p:cSld>
     <p:bg>
       <p:bgPr>
@@ -6278,7 +6372,14 @@
         <p:cNvGrpSpPr/>
         <p:nvPr/>
       </p:nvGrpSpPr>
-      <p:grpSpPr/>
+      <p:grpSpPr>
+        <a:xfrm>
+          <a:off x="0" y="0"/>
+          <a:ext cx="0" cy="0"/>
+          <a:chOff x="0" y="0"/>
+          <a:chExt cx="0" cy="0"/>
+        </a:xfrm>
+      </p:grpSpPr>
       <p:sp>
         <p:nvSpPr>
           <p:cNvPr id="2" name="Rectangle 1"/>
@@ -6319,6 +6420,7 @@
           <a:lstStyle/>
           <a:p>
             <a:pPr algn="ctr"/>
+            <a:endParaRPr/>
           </a:p>
         </p:txBody>
       </p:sp>
@@ -6362,6 +6464,7 @@
           <a:lstStyle/>
           <a:p>
             <a:pPr algn="ctr"/>
+            <a:endParaRPr/>
           </a:p>
         </p:txBody>
       </p:sp>
@@ -6405,6 +6508,7 @@
           <a:lstStyle/>
           <a:p>
             <a:pPr algn="ctr"/>
+            <a:endParaRPr/>
           </a:p>
         </p:txBody>
       </p:sp>
@@ -6720,7 +6824,7 @@
 </file>
 
 <file path=ppt/slides/slide20.xml><?xml version="1.0" encoding="utf-8"?>
-<p:sld xmlns:a="http://schemas.openxmlformats.org/drawingml/2006/main" xmlns:p="http://schemas.openxmlformats.org/presentationml/2006/main" xmlns:r="http://schemas.openxmlformats.org/officeDocument/2006/relationships">
+<p:sld xmlns:a="http://schemas.openxmlformats.org/drawingml/2006/main" xmlns:r="http://schemas.openxmlformats.org/officeDocument/2006/relationships" xmlns:p="http://schemas.openxmlformats.org/presentationml/2006/main">
   <p:cSld>
     <p:bg>
       <p:bgPr>
@@ -6736,7 +6840,14 @@
         <p:cNvGrpSpPr/>
         <p:nvPr/>
       </p:nvGrpSpPr>
-      <p:grpSpPr/>
+      <p:grpSpPr>
+        <a:xfrm>
+          <a:off x="0" y="0"/>
+          <a:ext cx="0" cy="0"/>
+          <a:chOff x="0" y="0"/>
+          <a:chExt cx="0" cy="0"/>
+        </a:xfrm>
+      </p:grpSpPr>
       <p:sp>
         <p:nvSpPr>
           <p:cNvPr id="2" name="Rectangle 1"/>
@@ -6777,6 +6888,7 @@
           <a:lstStyle/>
           <a:p>
             <a:pPr algn="ctr"/>
+            <a:endParaRPr/>
           </a:p>
         </p:txBody>
       </p:sp>
@@ -6957,7 +7069,7 @@
 </file>
 
 <file path=ppt/slides/slide21.xml><?xml version="1.0" encoding="utf-8"?>
-<p:sld xmlns:a="http://schemas.openxmlformats.org/drawingml/2006/main" xmlns:p="http://schemas.openxmlformats.org/presentationml/2006/main" xmlns:r="http://schemas.openxmlformats.org/officeDocument/2006/relationships">
+<p:sld xmlns:a="http://schemas.openxmlformats.org/drawingml/2006/main" xmlns:r="http://schemas.openxmlformats.org/officeDocument/2006/relationships" xmlns:p="http://schemas.openxmlformats.org/presentationml/2006/main">
   <p:cSld>
     <p:bg>
       <p:bgPr>
@@ -6973,7 +7085,14 @@
         <p:cNvGrpSpPr/>
         <p:nvPr/>
       </p:nvGrpSpPr>
-      <p:grpSpPr/>
+      <p:grpSpPr>
+        <a:xfrm>
+          <a:off x="0" y="0"/>
+          <a:ext cx="0" cy="0"/>
+          <a:chOff x="0" y="0"/>
+          <a:chExt cx="0" cy="0"/>
+        </a:xfrm>
+      </p:grpSpPr>
       <p:sp>
         <p:nvSpPr>
           <p:cNvPr id="2" name="Rectangle 1"/>
@@ -7014,6 +7133,7 @@
           <a:lstStyle/>
           <a:p>
             <a:pPr algn="ctr"/>
+            <a:endParaRPr/>
           </a:p>
         </p:txBody>
       </p:sp>
@@ -7309,7 +7429,7 @@
 </file>
 
 <file path=ppt/slides/slide22.xml><?xml version="1.0" encoding="utf-8"?>
-<p:sld xmlns:a="http://schemas.openxmlformats.org/drawingml/2006/main" xmlns:p="http://schemas.openxmlformats.org/presentationml/2006/main" xmlns:r="http://schemas.openxmlformats.org/officeDocument/2006/relationships">
+<p:sld xmlns:a="http://schemas.openxmlformats.org/drawingml/2006/main" xmlns:r="http://schemas.openxmlformats.org/officeDocument/2006/relationships" xmlns:p="http://schemas.openxmlformats.org/presentationml/2006/main">
   <p:cSld>
     <p:bg>
       <p:bgPr>
@@ -7325,7 +7445,14 @@
         <p:cNvGrpSpPr/>
         <p:nvPr/>
       </p:nvGrpSpPr>
-      <p:grpSpPr/>
+      <p:grpSpPr>
+        <a:xfrm>
+          <a:off x="0" y="0"/>
+          <a:ext cx="0" cy="0"/>
+          <a:chOff x="0" y="0"/>
+          <a:chExt cx="0" cy="0"/>
+        </a:xfrm>
+      </p:grpSpPr>
       <p:sp>
         <p:nvSpPr>
           <p:cNvPr id="2" name="Rectangle 1"/>
@@ -7366,6 +7493,7 @@
           <a:lstStyle/>
           <a:p>
             <a:pPr algn="ctr"/>
+            <a:endParaRPr/>
           </a:p>
         </p:txBody>
       </p:sp>
@@ -7546,7 +7674,7 @@
 </file>
 
 <file path=ppt/slides/slide23.xml><?xml version="1.0" encoding="utf-8"?>
-<p:sld xmlns:a="http://schemas.openxmlformats.org/drawingml/2006/main" xmlns:p="http://schemas.openxmlformats.org/presentationml/2006/main" xmlns:r="http://schemas.openxmlformats.org/officeDocument/2006/relationships">
+<p:sld xmlns:a="http://schemas.openxmlformats.org/drawingml/2006/main" xmlns:r="http://schemas.openxmlformats.org/officeDocument/2006/relationships" xmlns:p="http://schemas.openxmlformats.org/presentationml/2006/main">
   <p:cSld>
     <p:bg>
       <p:bgPr>
@@ -7562,7 +7690,14 @@
         <p:cNvGrpSpPr/>
         <p:nvPr/>
       </p:nvGrpSpPr>
-      <p:grpSpPr/>
+      <p:grpSpPr>
+        <a:xfrm>
+          <a:off x="0" y="0"/>
+          <a:ext cx="0" cy="0"/>
+          <a:chOff x="0" y="0"/>
+          <a:chExt cx="0" cy="0"/>
+        </a:xfrm>
+      </p:grpSpPr>
       <p:sp>
         <p:nvSpPr>
           <p:cNvPr id="2" name="Rectangle 1"/>
@@ -7603,6 +7738,7 @@
           <a:lstStyle/>
           <a:p>
             <a:pPr algn="ctr"/>
+            <a:endParaRPr/>
           </a:p>
         </p:txBody>
       </p:sp>
@@ -7783,7 +7919,7 @@
 </file>
 
 <file path=ppt/slides/slide24.xml><?xml version="1.0" encoding="utf-8"?>
-<p:sld xmlns:a="http://schemas.openxmlformats.org/drawingml/2006/main" xmlns:p="http://schemas.openxmlformats.org/presentationml/2006/main" xmlns:r="http://schemas.openxmlformats.org/officeDocument/2006/relationships">
+<p:sld xmlns:a="http://schemas.openxmlformats.org/drawingml/2006/main" xmlns:r="http://schemas.openxmlformats.org/officeDocument/2006/relationships" xmlns:p="http://schemas.openxmlformats.org/presentationml/2006/main">
   <p:cSld>
     <p:bg>
       <p:bgPr>
@@ -7799,7 +7935,14 @@
         <p:cNvGrpSpPr/>
         <p:nvPr/>
       </p:nvGrpSpPr>
-      <p:grpSpPr/>
+      <p:grpSpPr>
+        <a:xfrm>
+          <a:off x="0" y="0"/>
+          <a:ext cx="0" cy="0"/>
+          <a:chOff x="0" y="0"/>
+          <a:chExt cx="0" cy="0"/>
+        </a:xfrm>
+      </p:grpSpPr>
       <p:sp>
         <p:nvSpPr>
           <p:cNvPr id="2" name="Rectangle 1"/>
@@ -7840,6 +7983,7 @@
           <a:lstStyle/>
           <a:p>
             <a:pPr algn="ctr"/>
+            <a:endParaRPr/>
           </a:p>
         </p:txBody>
       </p:sp>
@@ -8020,7 +8164,7 @@
 </file>
 
 <file path=ppt/slides/slide25.xml><?xml version="1.0" encoding="utf-8"?>
-<p:sld xmlns:a="http://schemas.openxmlformats.org/drawingml/2006/main" xmlns:p="http://schemas.openxmlformats.org/presentationml/2006/main" xmlns:r="http://schemas.openxmlformats.org/officeDocument/2006/relationships">
+<p:sld xmlns:a="http://schemas.openxmlformats.org/drawingml/2006/main" xmlns:r="http://schemas.openxmlformats.org/officeDocument/2006/relationships" xmlns:p="http://schemas.openxmlformats.org/presentationml/2006/main">
   <p:cSld>
     <p:bg>
       <p:bgPr>
@@ -8036,7 +8180,14 @@
         <p:cNvGrpSpPr/>
         <p:nvPr/>
       </p:nvGrpSpPr>
-      <p:grpSpPr/>
+      <p:grpSpPr>
+        <a:xfrm>
+          <a:off x="0" y="0"/>
+          <a:ext cx="0" cy="0"/>
+          <a:chOff x="0" y="0"/>
+          <a:chExt cx="0" cy="0"/>
+        </a:xfrm>
+      </p:grpSpPr>
       <p:sp>
         <p:nvSpPr>
           <p:cNvPr id="2" name="Rectangle 1"/>
@@ -8077,6 +8228,7 @@
           <a:lstStyle/>
           <a:p>
             <a:pPr algn="ctr"/>
+            <a:endParaRPr/>
           </a:p>
         </p:txBody>
       </p:sp>
@@ -8257,7 +8409,7 @@
 </file>
 
 <file path=ppt/slides/slide26.xml><?xml version="1.0" encoding="utf-8"?>
-<p:sld xmlns:a="http://schemas.openxmlformats.org/drawingml/2006/main" xmlns:p="http://schemas.openxmlformats.org/presentationml/2006/main" xmlns:r="http://schemas.openxmlformats.org/officeDocument/2006/relationships">
+<p:sld xmlns:a="http://schemas.openxmlformats.org/drawingml/2006/main" xmlns:r="http://schemas.openxmlformats.org/officeDocument/2006/relationships" xmlns:p="http://schemas.openxmlformats.org/presentationml/2006/main">
   <p:cSld>
     <p:bg>
       <p:bgPr>
@@ -8273,7 +8425,14 @@
         <p:cNvGrpSpPr/>
         <p:nvPr/>
       </p:nvGrpSpPr>
-      <p:grpSpPr/>
+      <p:grpSpPr>
+        <a:xfrm>
+          <a:off x="0" y="0"/>
+          <a:ext cx="0" cy="0"/>
+          <a:chOff x="0" y="0"/>
+          <a:chExt cx="0" cy="0"/>
+        </a:xfrm>
+      </p:grpSpPr>
       <p:sp>
         <p:nvSpPr>
           <p:cNvPr id="2" name="Rectangle 1"/>
@@ -8314,6 +8473,7 @@
           <a:lstStyle/>
           <a:p>
             <a:pPr algn="ctr"/>
+            <a:endParaRPr/>
           </a:p>
         </p:txBody>
       </p:sp>
@@ -8494,7 +8654,7 @@
 </file>
 
 <file path=ppt/slides/slide27.xml><?xml version="1.0" encoding="utf-8"?>
-<p:sld xmlns:a="http://schemas.openxmlformats.org/drawingml/2006/main" xmlns:p="http://schemas.openxmlformats.org/presentationml/2006/main" xmlns:r="http://schemas.openxmlformats.org/officeDocument/2006/relationships">
+<p:sld xmlns:a="http://schemas.openxmlformats.org/drawingml/2006/main" xmlns:r="http://schemas.openxmlformats.org/officeDocument/2006/relationships" xmlns:p="http://schemas.openxmlformats.org/presentationml/2006/main">
   <p:cSld>
     <p:bg>
       <p:bgPr>
@@ -8510,7 +8670,14 @@
         <p:cNvGrpSpPr/>
         <p:nvPr/>
       </p:nvGrpSpPr>
-      <p:grpSpPr/>
+      <p:grpSpPr>
+        <a:xfrm>
+          <a:off x="0" y="0"/>
+          <a:ext cx="0" cy="0"/>
+          <a:chOff x="0" y="0"/>
+          <a:chExt cx="0" cy="0"/>
+        </a:xfrm>
+      </p:grpSpPr>
       <p:sp>
         <p:nvSpPr>
           <p:cNvPr id="2" name="Rectangle 1"/>
@@ -8551,6 +8718,7 @@
           <a:lstStyle/>
           <a:p>
             <a:pPr algn="ctr"/>
+            <a:endParaRPr/>
           </a:p>
         </p:txBody>
       </p:sp>
@@ -8743,7 +8911,7 @@
 </file>
 
 <file path=ppt/slides/slide28.xml><?xml version="1.0" encoding="utf-8"?>
-<p:sld xmlns:a="http://schemas.openxmlformats.org/drawingml/2006/main" xmlns:p="http://schemas.openxmlformats.org/presentationml/2006/main" xmlns:r="http://schemas.openxmlformats.org/officeDocument/2006/relationships">
+<p:sld xmlns:a="http://schemas.openxmlformats.org/drawingml/2006/main" xmlns:r="http://schemas.openxmlformats.org/officeDocument/2006/relationships" xmlns:p="http://schemas.openxmlformats.org/presentationml/2006/main">
   <p:cSld>
     <p:bg>
       <p:bgPr>
@@ -8759,7 +8927,14 @@
         <p:cNvGrpSpPr/>
         <p:nvPr/>
       </p:nvGrpSpPr>
-      <p:grpSpPr/>
+      <p:grpSpPr>
+        <a:xfrm>
+          <a:off x="0" y="0"/>
+          <a:ext cx="0" cy="0"/>
+          <a:chOff x="0" y="0"/>
+          <a:chExt cx="0" cy="0"/>
+        </a:xfrm>
+      </p:grpSpPr>
       <p:sp>
         <p:nvSpPr>
           <p:cNvPr id="2" name="Rectangle 1"/>
@@ -8800,6 +8975,7 @@
           <a:lstStyle/>
           <a:p>
             <a:pPr algn="ctr"/>
+            <a:endParaRPr/>
           </a:p>
         </p:txBody>
       </p:sp>
@@ -8980,7 +9156,7 @@
 </file>
 
 <file path=ppt/slides/slide29.xml><?xml version="1.0" encoding="utf-8"?>
-<p:sld xmlns:a="http://schemas.openxmlformats.org/drawingml/2006/main" xmlns:p="http://schemas.openxmlformats.org/presentationml/2006/main" xmlns:r="http://schemas.openxmlformats.org/officeDocument/2006/relationships">
+<p:sld xmlns:a="http://schemas.openxmlformats.org/drawingml/2006/main" xmlns:r="http://schemas.openxmlformats.org/officeDocument/2006/relationships" xmlns:p="http://schemas.openxmlformats.org/presentationml/2006/main">
   <p:cSld>
     <p:bg>
       <p:bgPr>
@@ -8996,7 +9172,14 @@
         <p:cNvGrpSpPr/>
         <p:nvPr/>
       </p:nvGrpSpPr>
-      <p:grpSpPr/>
+      <p:grpSpPr>
+        <a:xfrm>
+          <a:off x="0" y="0"/>
+          <a:ext cx="0" cy="0"/>
+          <a:chOff x="0" y="0"/>
+          <a:chExt cx="0" cy="0"/>
+        </a:xfrm>
+      </p:grpSpPr>
       <p:sp>
         <p:nvSpPr>
           <p:cNvPr id="2" name="Rectangle 1"/>
@@ -9037,6 +9220,7 @@
           <a:lstStyle/>
           <a:p>
             <a:pPr algn="ctr"/>
+            <a:endParaRPr/>
           </a:p>
         </p:txBody>
       </p:sp>
@@ -9253,7 +9437,7 @@
 </file>
 
 <file path=ppt/slides/slide3.xml><?xml version="1.0" encoding="utf-8"?>
-<p:sld xmlns:a="http://schemas.openxmlformats.org/drawingml/2006/main" xmlns:p="http://schemas.openxmlformats.org/presentationml/2006/main" xmlns:r="http://schemas.openxmlformats.org/officeDocument/2006/relationships">
+<p:sld xmlns:a="http://schemas.openxmlformats.org/drawingml/2006/main" xmlns:r="http://schemas.openxmlformats.org/officeDocument/2006/relationships" xmlns:p="http://schemas.openxmlformats.org/presentationml/2006/main">
   <p:cSld>
     <p:bg>
       <p:bgPr>
@@ -9269,7 +9453,14 @@
         <p:cNvGrpSpPr/>
         <p:nvPr/>
       </p:nvGrpSpPr>
-      <p:grpSpPr/>
+      <p:grpSpPr>
+        <a:xfrm>
+          <a:off x="0" y="0"/>
+          <a:ext cx="0" cy="0"/>
+          <a:chOff x="0" y="0"/>
+          <a:chExt cx="0" cy="0"/>
+        </a:xfrm>
+      </p:grpSpPr>
       <p:sp>
         <p:nvSpPr>
           <p:cNvPr id="2" name="Rectangle 1"/>
@@ -9310,6 +9501,7 @@
           <a:lstStyle/>
           <a:p>
             <a:pPr algn="ctr"/>
+            <a:endParaRPr/>
           </a:p>
         </p:txBody>
       </p:sp>
@@ -9429,7 +9621,7 @@
         </p:nvSpPr>
         <p:spPr>
           <a:xfrm>
-            <a:off x="731520" y="4389120"/>
+            <a:off x="731520" y="2720340"/>
             <a:ext cx="10515600" cy="1828800"/>
           </a:xfrm>
           <a:prstGeom prst="rect">
@@ -9452,6 +9644,7 @@
               </a:defRPr>
             </a:pPr>
             <a:r>
+              <a:rPr dirty="0"/>
               <a:t>You've spent five sessions learning about digital spaces, values, safeguarding, engagement mechanics, corporate power and young people's agency. Now describe what good actually looks like — not in theory, but from what you've seen and done. Today you build to those standards.</a:t>
             </a:r>
           </a:p>
@@ -9502,7 +9695,7 @@
 </file>
 
 <file path=ppt/slides/slide30.xml><?xml version="1.0" encoding="utf-8"?>
-<p:sld xmlns:a="http://schemas.openxmlformats.org/drawingml/2006/main" xmlns:p="http://schemas.openxmlformats.org/presentationml/2006/main" xmlns:r="http://schemas.openxmlformats.org/officeDocument/2006/relationships">
+<p:sld xmlns:a="http://schemas.openxmlformats.org/drawingml/2006/main" xmlns:r="http://schemas.openxmlformats.org/officeDocument/2006/relationships" xmlns:p="http://schemas.openxmlformats.org/presentationml/2006/main">
   <p:cSld>
     <p:bg>
       <p:bgPr>
@@ -9518,7 +9711,14 @@
         <p:cNvGrpSpPr/>
         <p:nvPr/>
       </p:nvGrpSpPr>
-      <p:grpSpPr/>
+      <p:grpSpPr>
+        <a:xfrm>
+          <a:off x="0" y="0"/>
+          <a:ext cx="0" cy="0"/>
+          <a:chOff x="0" y="0"/>
+          <a:chExt cx="0" cy="0"/>
+        </a:xfrm>
+      </p:grpSpPr>
       <p:sp>
         <p:nvSpPr>
           <p:cNvPr id="2" name="Rectangle 1"/>
@@ -9559,6 +9759,7 @@
           <a:lstStyle/>
           <a:p>
             <a:pPr algn="ctr"/>
+            <a:endParaRPr/>
           </a:p>
         </p:txBody>
       </p:sp>
@@ -9739,7 +9940,7 @@
 </file>
 
 <file path=ppt/slides/slide31.xml><?xml version="1.0" encoding="utf-8"?>
-<p:sld xmlns:a="http://schemas.openxmlformats.org/drawingml/2006/main" xmlns:p="http://schemas.openxmlformats.org/presentationml/2006/main" xmlns:r="http://schemas.openxmlformats.org/officeDocument/2006/relationships">
+<p:sld xmlns:a="http://schemas.openxmlformats.org/drawingml/2006/main" xmlns:r="http://schemas.openxmlformats.org/officeDocument/2006/relationships" xmlns:p="http://schemas.openxmlformats.org/presentationml/2006/main">
   <p:cSld>
     <p:bg>
       <p:bgPr>
@@ -9755,7 +9956,14 @@
         <p:cNvGrpSpPr/>
         <p:nvPr/>
       </p:nvGrpSpPr>
-      <p:grpSpPr/>
+      <p:grpSpPr>
+        <a:xfrm>
+          <a:off x="0" y="0"/>
+          <a:ext cx="0" cy="0"/>
+          <a:chOff x="0" y="0"/>
+          <a:chExt cx="0" cy="0"/>
+        </a:xfrm>
+      </p:grpSpPr>
       <p:sp>
         <p:nvSpPr>
           <p:cNvPr id="2" name="Rectangle 1"/>
@@ -9796,6 +10004,7 @@
           <a:lstStyle/>
           <a:p>
             <a:pPr algn="ctr"/>
+            <a:endParaRPr/>
           </a:p>
         </p:txBody>
       </p:sp>
@@ -9976,7 +10185,7 @@
 </file>
 
 <file path=ppt/slides/slide32.xml><?xml version="1.0" encoding="utf-8"?>
-<p:sld xmlns:a="http://schemas.openxmlformats.org/drawingml/2006/main" xmlns:p="http://schemas.openxmlformats.org/presentationml/2006/main" xmlns:r="http://schemas.openxmlformats.org/officeDocument/2006/relationships">
+<p:sld xmlns:a="http://schemas.openxmlformats.org/drawingml/2006/main" xmlns:r="http://schemas.openxmlformats.org/officeDocument/2006/relationships" xmlns:p="http://schemas.openxmlformats.org/presentationml/2006/main">
   <p:cSld>
     <p:bg>
       <p:bgPr>
@@ -9992,7 +10201,14 @@
         <p:cNvGrpSpPr/>
         <p:nvPr/>
       </p:nvGrpSpPr>
-      <p:grpSpPr/>
+      <p:grpSpPr>
+        <a:xfrm>
+          <a:off x="0" y="0"/>
+          <a:ext cx="0" cy="0"/>
+          <a:chOff x="0" y="0"/>
+          <a:chExt cx="0" cy="0"/>
+        </a:xfrm>
+      </p:grpSpPr>
       <p:sp>
         <p:nvSpPr>
           <p:cNvPr id="2" name="Rectangle 1"/>
@@ -10033,6 +10249,7 @@
           <a:lstStyle/>
           <a:p>
             <a:pPr algn="ctr"/>
+            <a:endParaRPr/>
           </a:p>
         </p:txBody>
       </p:sp>
@@ -10076,6 +10293,7 @@
           <a:lstStyle/>
           <a:p>
             <a:pPr algn="ctr"/>
+            <a:endParaRPr/>
           </a:p>
         </p:txBody>
       </p:sp>
@@ -10119,6 +10337,7 @@
           <a:lstStyle/>
           <a:p>
             <a:pPr algn="ctr"/>
+            <a:endParaRPr/>
           </a:p>
         </p:txBody>
       </p:sp>
@@ -10299,7 +10518,7 @@
 </file>
 
 <file path=ppt/slides/slide4.xml><?xml version="1.0" encoding="utf-8"?>
-<p:sld xmlns:a="http://schemas.openxmlformats.org/drawingml/2006/main" xmlns:p="http://schemas.openxmlformats.org/presentationml/2006/main" xmlns:r="http://schemas.openxmlformats.org/officeDocument/2006/relationships">
+<p:sld xmlns:a="http://schemas.openxmlformats.org/drawingml/2006/main" xmlns:r="http://schemas.openxmlformats.org/officeDocument/2006/relationships" xmlns:p="http://schemas.openxmlformats.org/presentationml/2006/main">
   <p:cSld>
     <p:bg>
       <p:bgPr>
@@ -10315,7 +10534,14 @@
         <p:cNvGrpSpPr/>
         <p:nvPr/>
       </p:nvGrpSpPr>
-      <p:grpSpPr/>
+      <p:grpSpPr>
+        <a:xfrm>
+          <a:off x="0" y="0"/>
+          <a:ext cx="0" cy="0"/>
+          <a:chOff x="0" y="0"/>
+          <a:chExt cx="0" cy="0"/>
+        </a:xfrm>
+      </p:grpSpPr>
       <p:sp>
         <p:nvSpPr>
           <p:cNvPr id="2" name="Rectangle 1"/>
@@ -10356,6 +10582,7 @@
           <a:lstStyle/>
           <a:p>
             <a:pPr algn="ctr"/>
+            <a:endParaRPr/>
           </a:p>
         </p:txBody>
       </p:sp>
@@ -10536,7 +10763,7 @@
 </file>
 
 <file path=ppt/slides/slide5.xml><?xml version="1.0" encoding="utf-8"?>
-<p:sld xmlns:a="http://schemas.openxmlformats.org/drawingml/2006/main" xmlns:p="http://schemas.openxmlformats.org/presentationml/2006/main" xmlns:r="http://schemas.openxmlformats.org/officeDocument/2006/relationships">
+<p:sld xmlns:a="http://schemas.openxmlformats.org/drawingml/2006/main" xmlns:r="http://schemas.openxmlformats.org/officeDocument/2006/relationships" xmlns:p="http://schemas.openxmlformats.org/presentationml/2006/main">
   <p:cSld>
     <p:bg>
       <p:bgPr>
@@ -10552,7 +10779,14 @@
         <p:cNvGrpSpPr/>
         <p:nvPr/>
       </p:nvGrpSpPr>
-      <p:grpSpPr/>
+      <p:grpSpPr>
+        <a:xfrm>
+          <a:off x="0" y="0"/>
+          <a:ext cx="0" cy="0"/>
+          <a:chOff x="0" y="0"/>
+          <a:chExt cx="0" cy="0"/>
+        </a:xfrm>
+      </p:grpSpPr>
       <p:sp>
         <p:nvSpPr>
           <p:cNvPr id="2" name="Rectangle 1"/>
@@ -10593,6 +10827,7 @@
           <a:lstStyle/>
           <a:p>
             <a:pPr algn="ctr"/>
+            <a:endParaRPr/>
           </a:p>
         </p:txBody>
       </p:sp>
@@ -10773,7 +11008,7 @@
 </file>
 
 <file path=ppt/slides/slide6.xml><?xml version="1.0" encoding="utf-8"?>
-<p:sld xmlns:a="http://schemas.openxmlformats.org/drawingml/2006/main" xmlns:p="http://schemas.openxmlformats.org/presentationml/2006/main" xmlns:r="http://schemas.openxmlformats.org/officeDocument/2006/relationships">
+<p:sld xmlns:a="http://schemas.openxmlformats.org/drawingml/2006/main" xmlns:r="http://schemas.openxmlformats.org/officeDocument/2006/relationships" xmlns:p="http://schemas.openxmlformats.org/presentationml/2006/main">
   <p:cSld>
     <p:bg>
       <p:bgPr>
@@ -10789,7 +11024,14 @@
         <p:cNvGrpSpPr/>
         <p:nvPr/>
       </p:nvGrpSpPr>
-      <p:grpSpPr/>
+      <p:grpSpPr>
+        <a:xfrm>
+          <a:off x="0" y="0"/>
+          <a:ext cx="0" cy="0"/>
+          <a:chOff x="0" y="0"/>
+          <a:chExt cx="0" cy="0"/>
+        </a:xfrm>
+      </p:grpSpPr>
       <p:sp>
         <p:nvSpPr>
           <p:cNvPr id="2" name="Rectangle 1"/>
@@ -10830,6 +11072,7 @@
           <a:lstStyle/>
           <a:p>
             <a:pPr algn="ctr"/>
+            <a:endParaRPr/>
           </a:p>
         </p:txBody>
       </p:sp>
@@ -11046,7 +11289,7 @@
 </file>
 
 <file path=ppt/slides/slide7.xml><?xml version="1.0" encoding="utf-8"?>
-<p:sld xmlns:a="http://schemas.openxmlformats.org/drawingml/2006/main" xmlns:p="http://schemas.openxmlformats.org/presentationml/2006/main" xmlns:r="http://schemas.openxmlformats.org/officeDocument/2006/relationships">
+<p:sld xmlns:a="http://schemas.openxmlformats.org/drawingml/2006/main" xmlns:r="http://schemas.openxmlformats.org/officeDocument/2006/relationships" xmlns:p="http://schemas.openxmlformats.org/presentationml/2006/main">
   <p:cSld>
     <p:bg>
       <p:bgPr>
@@ -11062,7 +11305,14 @@
         <p:cNvGrpSpPr/>
         <p:nvPr/>
       </p:nvGrpSpPr>
-      <p:grpSpPr/>
+      <p:grpSpPr>
+        <a:xfrm>
+          <a:off x="0" y="0"/>
+          <a:ext cx="0" cy="0"/>
+          <a:chOff x="0" y="0"/>
+          <a:chExt cx="0" cy="0"/>
+        </a:xfrm>
+      </p:grpSpPr>
       <p:sp>
         <p:nvSpPr>
           <p:cNvPr id="2" name="Rectangle 1"/>
@@ -11103,6 +11353,7 @@
           <a:lstStyle/>
           <a:p>
             <a:pPr algn="ctr"/>
+            <a:endParaRPr/>
           </a:p>
         </p:txBody>
       </p:sp>
@@ -11283,7 +11534,7 @@
 </file>
 
 <file path=ppt/slides/slide8.xml><?xml version="1.0" encoding="utf-8"?>
-<p:sld xmlns:a="http://schemas.openxmlformats.org/drawingml/2006/main" xmlns:p="http://schemas.openxmlformats.org/presentationml/2006/main" xmlns:r="http://schemas.openxmlformats.org/officeDocument/2006/relationships">
+<p:sld xmlns:a="http://schemas.openxmlformats.org/drawingml/2006/main" xmlns:r="http://schemas.openxmlformats.org/officeDocument/2006/relationships" xmlns:p="http://schemas.openxmlformats.org/presentationml/2006/main">
   <p:cSld>
     <p:bg>
       <p:bgPr>
@@ -11299,7 +11550,14 @@
         <p:cNvGrpSpPr/>
         <p:nvPr/>
       </p:nvGrpSpPr>
-      <p:grpSpPr/>
+      <p:grpSpPr>
+        <a:xfrm>
+          <a:off x="0" y="0"/>
+          <a:ext cx="0" cy="0"/>
+          <a:chOff x="0" y="0"/>
+          <a:chExt cx="0" cy="0"/>
+        </a:xfrm>
+      </p:grpSpPr>
       <p:sp>
         <p:nvSpPr>
           <p:cNvPr id="2" name="Rectangle 1"/>
@@ -11340,6 +11598,7 @@
           <a:lstStyle/>
           <a:p>
             <a:pPr algn="ctr"/>
+            <a:endParaRPr/>
           </a:p>
         </p:txBody>
       </p:sp>
@@ -11520,7 +11779,7 @@
 </file>
 
 <file path=ppt/slides/slide9.xml><?xml version="1.0" encoding="utf-8"?>
-<p:sld xmlns:a="http://schemas.openxmlformats.org/drawingml/2006/main" xmlns:p="http://schemas.openxmlformats.org/presentationml/2006/main" xmlns:r="http://schemas.openxmlformats.org/officeDocument/2006/relationships">
+<p:sld xmlns:a="http://schemas.openxmlformats.org/drawingml/2006/main" xmlns:r="http://schemas.openxmlformats.org/officeDocument/2006/relationships" xmlns:p="http://schemas.openxmlformats.org/presentationml/2006/main">
   <p:cSld>
     <p:bg>
       <p:bgPr>
@@ -11536,7 +11795,14 @@
         <p:cNvGrpSpPr/>
         <p:nvPr/>
       </p:nvGrpSpPr>
-      <p:grpSpPr/>
+      <p:grpSpPr>
+        <a:xfrm>
+          <a:off x="0" y="0"/>
+          <a:ext cx="0" cy="0"/>
+          <a:chOff x="0" y="0"/>
+          <a:chExt cx="0" cy="0"/>
+        </a:xfrm>
+      </p:grpSpPr>
       <p:sp>
         <p:nvSpPr>
           <p:cNvPr id="2" name="Rectangle 1"/>
@@ -11577,6 +11843,7 @@
           <a:lstStyle/>
           <a:p>
             <a:pPr algn="ctr"/>
+            <a:endParaRPr/>
           </a:p>
         </p:txBody>
       </p:sp>

</xml_diff>